<commit_message>
fix: successfully embed user ERD image in slide 4 and push
</commit_message>
<xml_diff>
--- a/L_AROME_Presentation.pptx
+++ b/L_AROME_Presentation.pptx
@@ -3768,6 +3768,30 @@
           </a:p>
         </p:txBody>
       </p:sp>
+      <p:pic>
+        <p:nvPicPr>
+          <p:cNvPr id="5" name="Picture 4" descr="media__1784100070910.png"/>
+          <p:cNvPicPr>
+            <a:picLocks noChangeAspect="1"/>
+          </p:cNvPicPr>
+          <p:nvPr/>
+        </p:nvPicPr>
+        <p:blipFill>
+          <a:blip r:embed="rId2"/>
+          <a:stretch>
+            <a:fillRect/>
+          </a:stretch>
+        </p:blipFill>
+        <p:spPr>
+          <a:xfrm>
+            <a:off x="6217920" y="1645920"/>
+            <a:ext cx="5212080" cy="2784187"/>
+          </a:xfrm>
+          <a:prstGeom prst="rect">
+            <a:avLst/>
+          </a:prstGeom>
+        </p:spPr>
+      </p:pic>
     </p:spTree>
   </p:cSld>
   <p:clrMapOvr>

</xml_diff>

<commit_message>
fix: replace ERD image with new user upload in slide 4 and push
</commit_message>
<xml_diff>
--- a/L_AROME_Presentation.pptx
+++ b/L_AROME_Presentation.pptx
@@ -3770,7 +3770,7 @@
       </p:sp>
       <p:pic>
         <p:nvPicPr>
-          <p:cNvPr id="5" name="Picture 4" descr="media__1784100070910.png"/>
+          <p:cNvPr id="5" name="Picture 4" descr="media__1784168928988.png"/>
           <p:cNvPicPr>
             <a:picLocks noChangeAspect="1"/>
           </p:cNvPicPr>
@@ -3785,7 +3785,7 @@
         <p:spPr>
           <a:xfrm>
             <a:off x="6217920" y="1645920"/>
-            <a:ext cx="5212080" cy="2784187"/>
+            <a:ext cx="5212080" cy="2280285"/>
           </a:xfrm>
           <a:prstGeom prst="rect">
             <a:avLst/>

</xml_diff>